<commit_message>
chore(templates): update pptx templates, bundle IRNazanin fonts
</commit_message>
<xml_diff>
--- a/templates/certificate_template.pptx
+++ b/templates/certificate_template.pptx
@@ -272,7 +272,7 @@
           <a:p>
             <a:fld id="{CDDC06C2-7DBC-4F52-9B39-8D808E2DB5D5}" type="datetimeFigureOut">
               <a:rPr lang="en-US" smtClean="0"/>
-              <a:t>8/30/2026</a:t>
+              <a:t>9/8/2026</a:t>
             </a:fld>
             <a:endParaRPr lang="en-US"/>
           </a:p>
@@ -442,7 +442,7 @@
           <a:p>
             <a:fld id="{CDDC06C2-7DBC-4F52-9B39-8D808E2DB5D5}" type="datetimeFigureOut">
               <a:rPr lang="en-US" smtClean="0"/>
-              <a:t>8/30/2026</a:t>
+              <a:t>9/8/2026</a:t>
             </a:fld>
             <a:endParaRPr lang="en-US"/>
           </a:p>
@@ -622,7 +622,7 @@
           <a:p>
             <a:fld id="{CDDC06C2-7DBC-4F52-9B39-8D808E2DB5D5}" type="datetimeFigureOut">
               <a:rPr lang="en-US" smtClean="0"/>
-              <a:t>8/30/2026</a:t>
+              <a:t>9/8/2026</a:t>
             </a:fld>
             <a:endParaRPr lang="en-US"/>
           </a:p>
@@ -792,7 +792,7 @@
           <a:p>
             <a:fld id="{CDDC06C2-7DBC-4F52-9B39-8D808E2DB5D5}" type="datetimeFigureOut">
               <a:rPr lang="en-US" smtClean="0"/>
-              <a:t>8/30/2026</a:t>
+              <a:t>9/8/2026</a:t>
             </a:fld>
             <a:endParaRPr lang="en-US"/>
           </a:p>
@@ -1036,7 +1036,7 @@
           <a:p>
             <a:fld id="{CDDC06C2-7DBC-4F52-9B39-8D808E2DB5D5}" type="datetimeFigureOut">
               <a:rPr lang="en-US" smtClean="0"/>
-              <a:t>8/30/2026</a:t>
+              <a:t>9/8/2026</a:t>
             </a:fld>
             <a:endParaRPr lang="en-US"/>
           </a:p>
@@ -1268,7 +1268,7 @@
           <a:p>
             <a:fld id="{CDDC06C2-7DBC-4F52-9B39-8D808E2DB5D5}" type="datetimeFigureOut">
               <a:rPr lang="en-US" smtClean="0"/>
-              <a:t>8/30/2026</a:t>
+              <a:t>9/8/2026</a:t>
             </a:fld>
             <a:endParaRPr lang="en-US"/>
           </a:p>
@@ -1635,7 +1635,7 @@
           <a:p>
             <a:fld id="{CDDC06C2-7DBC-4F52-9B39-8D808E2DB5D5}" type="datetimeFigureOut">
               <a:rPr lang="en-US" smtClean="0"/>
-              <a:t>8/30/2026</a:t>
+              <a:t>9/8/2026</a:t>
             </a:fld>
             <a:endParaRPr lang="en-US"/>
           </a:p>
@@ -1753,7 +1753,7 @@
           <a:p>
             <a:fld id="{CDDC06C2-7DBC-4F52-9B39-8D808E2DB5D5}" type="datetimeFigureOut">
               <a:rPr lang="en-US" smtClean="0"/>
-              <a:t>8/30/2026</a:t>
+              <a:t>9/8/2026</a:t>
             </a:fld>
             <a:endParaRPr lang="en-US"/>
           </a:p>
@@ -1848,7 +1848,7 @@
           <a:p>
             <a:fld id="{CDDC06C2-7DBC-4F52-9B39-8D808E2DB5D5}" type="datetimeFigureOut">
               <a:rPr lang="en-US" smtClean="0"/>
-              <a:t>8/30/2026</a:t>
+              <a:t>9/8/2026</a:t>
             </a:fld>
             <a:endParaRPr lang="en-US"/>
           </a:p>
@@ -2125,7 +2125,7 @@
           <a:p>
             <a:fld id="{CDDC06C2-7DBC-4F52-9B39-8D808E2DB5D5}" type="datetimeFigureOut">
               <a:rPr lang="en-US" smtClean="0"/>
-              <a:t>8/30/2026</a:t>
+              <a:t>9/8/2026</a:t>
             </a:fld>
             <a:endParaRPr lang="en-US"/>
           </a:p>
@@ -2382,7 +2382,7 @@
           <a:p>
             <a:fld id="{CDDC06C2-7DBC-4F52-9B39-8D808E2DB5D5}" type="datetimeFigureOut">
               <a:rPr lang="en-US" smtClean="0"/>
-              <a:t>8/30/2026</a:t>
+              <a:t>9/8/2026</a:t>
             </a:fld>
             <a:endParaRPr lang="en-US"/>
           </a:p>
@@ -2595,7 +2595,7 @@
           <a:p>
             <a:fld id="{CDDC06C2-7DBC-4F52-9B39-8D808E2DB5D5}" type="datetimeFigureOut">
               <a:rPr lang="en-US" smtClean="0"/>
-              <a:t>8/30/2026</a:t>
+              <a:t>9/8/2026</a:t>
             </a:fld>
             <a:endParaRPr lang="en-US"/>
           </a:p>
@@ -3002,77 +3002,6 @@
       </p:grpSpPr>
       <p:sp>
         <p:nvSpPr>
-          <p:cNvPr id="8" name="TextBox 7">
-            <a:extLst>
-              <a:ext uri="{FF2B5EF4-FFF2-40B4-BE49-F238E27FC236}">
-                <a16:creationId xmlns:a16="http://schemas.microsoft.com/office/drawing/2014/main" id="{30A14EFB-F4EA-4330-A1BB-728D12A1EC40}"/>
-              </a:ext>
-            </a:extLst>
-          </p:cNvPr>
-          <p:cNvSpPr txBox="1"/>
-          <p:nvPr/>
-        </p:nvSpPr>
-        <p:spPr>
-          <a:xfrm>
-            <a:off x="865949" y="6636354"/>
-            <a:ext cx="1401345" cy="646331"/>
-          </a:xfrm>
-          <a:prstGeom prst="rect">
-            <a:avLst/>
-          </a:prstGeom>
-          <a:noFill/>
-        </p:spPr>
-        <p:txBody>
-          <a:bodyPr wrap="none" rtlCol="0">
-            <a:spAutoFit/>
-          </a:bodyPr>
-          <a:lstStyle/>
-          <a:p>
-            <a:pPr algn="ctr" rtl="1"/>
-            <a:r>
-              <a:rPr lang="en-US" sz="1200" dirty="0">
-                <a:latin typeface="IRLotus" panose="02000503000000020002" pitchFamily="2" charset="-78"/>
-                <a:cs typeface="IRLotus" panose="02000503000000020002" pitchFamily="2" charset="-78"/>
-              </a:rPr>
-              <a:t>{{signatory}}</a:t>
-            </a:r>
-            <a:endParaRPr lang="fa-IR" sz="1200" dirty="0">
-              <a:latin typeface="IRLotus" panose="02000503000000020002" pitchFamily="2" charset="-78"/>
-              <a:cs typeface="IRLotus" panose="02000503000000020002" pitchFamily="2" charset="-78"/>
-            </a:endParaRPr>
-          </a:p>
-          <a:p>
-            <a:pPr algn="ctr" rtl="1"/>
-            <a:r>
-              <a:rPr lang="en-US" sz="1200" dirty="0">
-                <a:latin typeface="IRLotus" panose="02000503000000020002" pitchFamily="2" charset="-78"/>
-                <a:cs typeface="IRLotus" panose="02000503000000020002" pitchFamily="2" charset="-78"/>
-              </a:rPr>
-              <a:t>{{position}}</a:t>
-            </a:r>
-            <a:endParaRPr lang="fa-IR" sz="1200" dirty="0">
-              <a:latin typeface="IRLotus" panose="02000503000000020002" pitchFamily="2" charset="-78"/>
-              <a:cs typeface="IRLotus" panose="02000503000000020002" pitchFamily="2" charset="-78"/>
-            </a:endParaRPr>
-          </a:p>
-          <a:p>
-            <a:pPr algn="ctr" rtl="1"/>
-            <a:r>
-              <a:rPr lang="fa-IR" sz="1200" dirty="0">
-                <a:latin typeface="IRLotus" panose="02000503000000020002" pitchFamily="2" charset="-78"/>
-                <a:cs typeface="IRLotus" panose="02000503000000020002" pitchFamily="2" charset="-78"/>
-              </a:rPr>
-              <a:t>مجتمع آموزش عالی ﻻرستان</a:t>
-            </a:r>
-            <a:endParaRPr lang="en-US" sz="1200" dirty="0">
-              <a:latin typeface="IRLotus" panose="02000503000000020002" pitchFamily="2" charset="-78"/>
-              <a:cs typeface="IRLotus" panose="02000503000000020002" pitchFamily="2" charset="-78"/>
-            </a:endParaRPr>
-          </a:p>
-        </p:txBody>
-      </p:sp>
-      <p:sp>
-        <p:nvSpPr>
           <p:cNvPr id="6" name="Rectangle 5">
             <a:extLst>
               <a:ext uri="{FF2B5EF4-FFF2-40B4-BE49-F238E27FC236}">
@@ -3431,7 +3360,7 @@
           </a:bodyPr>
           <a:lstStyle/>
           <a:p>
-            <a:pPr marL="164485" algn="just" rtl="1">
+            <a:pPr marL="164485" algn="r" rtl="1">
               <a:lnSpc>
                 <a:spcPct val="200000"/>
               </a:lnSpc>
@@ -3451,7 +3380,7 @@
             </a:endParaRPr>
           </a:p>
           <a:p>
-            <a:pPr marL="164485" algn="just" rtl="1">
+            <a:pPr marL="164485" algn="r" rtl="1">
               <a:lnSpc>
                 <a:spcPct val="200000"/>
               </a:lnSpc>
@@ -3486,10 +3415,18 @@
                 <a:ea typeface="Times New Roman" panose="02020603050405020304" pitchFamily="18" charset="0"/>
                 <a:cs typeface="IRLotus" panose="02000503000000020002" pitchFamily="2" charset="-78"/>
               </a:rPr>
-              <a:t> به شماره ملی </a:t>
-            </a:r>
-            <a:r>
-              <a:rPr lang="en-US" dirty="0">
+              <a:t> </a:t>
+            </a:r>
+            <a:r>
+              <a:rPr lang="fa-IR" sz="2400" dirty="0">
+                <a:latin typeface="IRLotus" panose="02000503000000020002" pitchFamily="2" charset="-78"/>
+                <a:ea typeface="Times New Roman" panose="02020603050405020304" pitchFamily="18" charset="0"/>
+                <a:cs typeface="IRLotus" panose="02000503000000020002" pitchFamily="2" charset="-78"/>
+              </a:rPr>
+              <a:t>به شماره ملی </a:t>
+            </a:r>
+            <a:r>
+              <a:rPr lang="en-US" b="1" dirty="0">
                 <a:latin typeface="Vazirmatn FD" panose="020B0604020202020204" charset="-78"/>
                 <a:ea typeface="Times New Roman" panose="02020603050405020304" pitchFamily="18" charset="0"/>
                 <a:cs typeface="Vazirmatn FD" panose="020B0604020202020204" charset="-78"/>
@@ -3835,7 +3772,7 @@
                   <a:latin typeface="IRLotus" panose="02000503000000020002" pitchFamily="2" charset="-78"/>
                   <a:cs typeface="IRLotus" panose="02000503000000020002" pitchFamily="2" charset="-78"/>
                 </a:rPr>
-                <a:t>     گواهی شرکت در  دوره آموزشی</a:t>
+                <a:t>     گواهی شرکت در  دوره</a:t>
               </a:r>
               <a:endParaRPr lang="en-US" sz="1600" dirty="0">
                 <a:latin typeface="IRLotus" panose="02000503000000020002" pitchFamily="2" charset="-78"/>
@@ -3959,8 +3896,8 @@
         </p:nvSpPr>
         <p:spPr>
           <a:xfrm>
-            <a:off x="1027456" y="781794"/>
-            <a:ext cx="693922" cy="307777"/>
+            <a:off x="-353246" y="781794"/>
+            <a:ext cx="2074624" cy="307777"/>
           </a:xfrm>
           <a:prstGeom prst="rect">
             <a:avLst/>
@@ -3982,46 +3919,8 @@
                 <a:latin typeface="IRLotus" panose="02000503000000020002" pitchFamily="2" charset="-78"/>
                 <a:cs typeface="IRLotus" panose="02000503000000020002" pitchFamily="2" charset="-78"/>
               </a:rPr>
-              <a:t>شماره:</a:t>
-            </a:r>
-            <a:endParaRPr lang="en-US" sz="1400" b="1" dirty="0">
-              <a:solidFill>
-                <a:schemeClr val="bg1"/>
-              </a:solidFill>
-              <a:latin typeface="IRLotus" panose="02000503000000020002" pitchFamily="2" charset="-78"/>
-              <a:cs typeface="IRLotus" panose="02000503000000020002" pitchFamily="2" charset="-78"/>
-            </a:endParaRPr>
-          </a:p>
-        </p:txBody>
-      </p:sp>
-      <p:sp>
-        <p:nvSpPr>
-          <p:cNvPr id="17" name="TextBox 16">
-            <a:extLst>
-              <a:ext uri="{FF2B5EF4-FFF2-40B4-BE49-F238E27FC236}">
-                <a16:creationId xmlns:a16="http://schemas.microsoft.com/office/drawing/2014/main" id="{1715E897-B2D7-4933-99AF-8C49E46B672B}"/>
-              </a:ext>
-            </a:extLst>
-          </p:cNvPr>
-          <p:cNvSpPr txBox="1"/>
-          <p:nvPr/>
-        </p:nvSpPr>
-        <p:spPr>
-          <a:xfrm>
-            <a:off x="212446" y="800896"/>
-            <a:ext cx="1326195" cy="261610"/>
-          </a:xfrm>
-          <a:prstGeom prst="rect">
-            <a:avLst/>
-          </a:prstGeom>
-          <a:noFill/>
-        </p:spPr>
-        <p:txBody>
-          <a:bodyPr wrap="square">
-            <a:spAutoFit/>
-          </a:bodyPr>
-          <a:lstStyle/>
-          <a:p>
+              <a:t>شماره:  </a:t>
+            </a:r>
             <a:r>
               <a:rPr lang="en-US" sz="1100" b="1" dirty="0">
                 <a:solidFill>
@@ -4049,7 +3948,7 @@
         </p:nvSpPr>
         <p:spPr>
           <a:xfrm>
-            <a:off x="6916816" y="5937641"/>
+            <a:off x="7178459" y="5917833"/>
             <a:ext cx="1171137" cy="1170628"/>
           </a:xfrm>
           <a:prstGeom prst="rect">
@@ -4115,8 +4014,8 @@
         </p:nvSpPr>
         <p:spPr>
           <a:xfrm>
-            <a:off x="450717" y="5465726"/>
-            <a:ext cx="2335255" cy="1170628"/>
+            <a:off x="450717" y="4926184"/>
+            <a:ext cx="3140208" cy="2182085"/>
           </a:xfrm>
           <a:prstGeom prst="rect">
             <a:avLst/>
@@ -4181,7 +4080,7 @@
         </p:nvSpPr>
         <p:spPr>
           <a:xfrm>
-            <a:off x="8195433" y="5942389"/>
+            <a:off x="8457076" y="5933745"/>
             <a:ext cx="1153551" cy="1154716"/>
           </a:xfrm>
           <a:prstGeom prst="rect">

</xml_diff>